<commit_message>
docs: identifica AB ED&IA Soluções em Tecnologia Ltda. como titular
Razão social e CNPJ no README, no rodapé da landing page e na apresentação.

Co-Authored-By: Claude Opus 5.5 <noreply@anthropic.com>
Claude-Session: https://claude.ai/code/session_01J7VYW1w8shnyepesemCzTG
</commit_message>
<xml_diff>
--- a/lexzenit/media/lexzenit-juridico.pptx
+++ b/lexzenit/media/lexzenit-juridico.pptx
@@ -121,14 +121,14 @@
   <p:extLst>
     <p:ext uri="{521415D9-36F7-43E2-AB2F-B90AF26B5E84}">
       <p14:sectionLst xmlns:p14="http://schemas.microsoft.com/office/powerpoint/2010/main">
-        <p14:section name="Abertura" id="{0d917086-a439-9a4b-a45f-1cbb058c7b7f}">
+        <p14:section name="Abertura" id="{e687f710-72bf-d7e0-14f3-af8526465880}">
           <p14:sldIdLst>
             <p14:sldId id="256"/>
             <p14:sldId id="257"/>
             <p14:sldId id="258"/>
           </p14:sldIdLst>
         </p14:section>
-        <p14:section name="Como funciona" id="{6282bfa2-c748-e510-3905-6bdbb14a434c}">
+        <p14:section name="Como funciona" id="{f571d5d8-86f3-d55f-0625-2926b35fb3b8}">
           <p14:sldIdLst>
             <p14:sldId id="259"/>
             <p14:sldId id="260"/>
@@ -137,19 +137,19 @@
             <p14:sldId id="263"/>
           </p14:sldIdLst>
         </p14:section>
-        <p14:section name="Arquitetura" id="{6871fd77-e6a5-2303-9583-d8bdc0c5b9fa}">
+        <p14:section name="Arquitetura" id="{54a4e753-4aaa-894e-0f4c-3c44ac58a334}">
           <p14:sldIdLst>
             <p14:sldId id="264"/>
             <p14:sldId id="265"/>
           </p14:sldIdLst>
         </p14:section>
-        <p14:section name="Cobertura e limites" id="{ca23f13a-da4c-7cd3-3e5d-39b55ec1da24}">
+        <p14:section name="Cobertura e limites" id="{03269852-43f2-85ef-8ce3-d436e13b3caf}">
           <p14:sldIdLst>
             <p14:sldId id="266"/>
             <p14:sldId id="267"/>
           </p14:sldIdLst>
         </p14:section>
-        <p14:section name="Começar" id="{504026ab-ceac-c11d-620f-de300fd0bc63}">
+        <p14:section name="Começar" id="{88bd7f08-7edd-8f38-5357-dec4d7070f87}">
           <p14:sldIdLst>
             <p14:sldId id="268"/>
             <p14:sldId id="269"/>
@@ -6645,7 +6645,7 @@
                 <a:ea typeface="Courier New" pitchFamily="34" charset="-122"/>
                 <a:cs typeface="Courier New" pitchFamily="34" charset="-120"/>
               </a:rPr>
-              <a:t>LEXZENIT · SKILL JURÍDICA · CLAUDE-FOR-LEGAL-BR 0.2.0 · APACHE-2.0</a:t>
+              <a:t>LEXZENIT · AB ED&amp;IA SOLUÇÕES EM TECNOLOGIA LTDA. · CNPJ 57.531.384/0001-96 · APACHE-2.0</a:t>
             </a:r>
             <a:endParaRPr lang="en-US" sz="1000" dirty="0"/>
           </a:p>

</xml_diff>